<commit_message>
Improve model training and update reporting evidence
</commit_message>
<xml_diff>
--- a/report/mlops_project_presentation.pptx
+++ b/report/mlops_project_presentation.pptx
@@ -3771,7 +3771,7 @@
                 <a:ea typeface="Calibri" pitchFamily="34" charset="-122"/>
                 <a:cs typeface="Calibri" pitchFamily="34" charset="-120"/>
               </a:rPr>
-              <a:t>The service handled 100 prediction requests with 0 HTTP errors, but the demo model predicted the fallback class other with low confidence. Monitoring exposed a model-quality issue, not an API failure.</a:t>
+              <a:t>The service handled 200 prediction requests with 0 HTTP errors. Monitoring showed predictions across all classes with average confidence around 0.9285.</a:t>
             </a:r>
             <a:endParaRPr lang="en-US" sz="1020" dirty="0"/>
           </a:p>
@@ -4250,7 +4250,7 @@
                 <a:ea typeface="Calibri" pitchFamily="34" charset="-122"/>
                 <a:cs typeface="Calibri" pitchFamily="34" charset="-120"/>
               </a:rPr>
-              <a:t>Small CI training sample</a:t>
+              <a:t>Small local training dataset</a:t>
             </a:r>
             <a:endParaRPr lang="en-US" sz="1200" dirty="0"/>
           </a:p>
@@ -4268,7 +4268,7 @@
                 <a:ea typeface="Calibri" pitchFamily="34" charset="-122"/>
                 <a:cs typeface="Calibri" pitchFamily="34" charset="-120"/>
               </a:rPr>
-              <a:t>Low model quality in the demo run</a:t>
+              <a:t>Stricter F1 deployment gate</a:t>
             </a:r>
             <a:endParaRPr lang="en-US" sz="1200" dirty="0"/>
           </a:p>
@@ -4448,7 +4448,7 @@
                 <a:ea typeface="Calibri" pitchFamily="34" charset="-122"/>
                 <a:cs typeface="Calibri" pitchFamily="34" charset="-120"/>
               </a:rPr>
-              <a:t>Train longer with more data</a:t>
+              <a:t>Add more labeled training data</a:t>
             </a:r>
             <a:endParaRPr lang="en-US" sz="1200" dirty="0"/>
           </a:p>
@@ -4466,7 +4466,7 @@
                 <a:ea typeface="Calibri" pitchFamily="34" charset="-122"/>
                 <a:cs typeface="Calibri" pitchFamily="34" charset="-120"/>
               </a:rPr>
-              <a:t>Raise deployment thresholds</a:t>
+              <a:t>Calibrate release thresholds</a:t>
             </a:r>
             <a:endParaRPr lang="en-US" sz="1200" dirty="0"/>
           </a:p>
@@ -12992,7 +12992,7 @@
                 <a:ea typeface="Calibri" pitchFamily="34" charset="-122"/>
                 <a:cs typeface="Calibri" pitchFamily="34" charset="-120"/>
               </a:rPr>
-              <a:t>Demo gate: weighted F1 = 0.20147 passed MIN_F1 = 0.15 for the fast CI run.</a:t>
+              <a:t>Jenkins gate: weighted F1 = 0.9055 passed MIN_F1 = 0.85 and promoted the model.</a:t>
             </a:r>
             <a:endParaRPr lang="en-US" sz="920" dirty="0"/>
           </a:p>

</xml_diff>